<commit_message>
Add Netlify live demo + CSV findings export
- Live demo: a static snapshot of the dashboard rendered from the REAL pipeline output
  (scripts/build_static_demo.py + netlify.toml), hosted at finoptic-shanto-demo.netlify.app.
  Netlify can't run the FastAPI backend, so the build bakes genuine output and serves the
  same dashboard UI client-side via a flag-guarded demo shim in api().
- New: GET /api/v1/export/findings.csv (+ SDK findings_csv + tests). 51 tests, 86% coverage.
- README / SUBMISSION / prompts.md / deck updated with the live demo link.

Co-Authored-By: Claude Opus 4.8 <noreply@anthropic.com>
</commit_message>
<xml_diff>
--- a/docs/FinOptic_Deck.pptx
+++ b/docs/FinOptic_Deck.pptx
@@ -2585,7 +2585,7 @@
                 <a:ea typeface="Georgia" pitchFamily="34" charset="-122"/>
                 <a:cs typeface="Georgia" pitchFamily="34" charset="-120"/>
               </a:rPr>
-              <a:t>API-first · 50 tests</a:t>
+              <a:t>Live demo · 51 tests</a:t>
             </a:r>
             <a:endParaRPr lang="en-US" sz="2700" dirty="0"/>
           </a:p>
@@ -2624,7 +2624,7 @@
                 <a:ea typeface="Calibri" pitchFamily="34" charset="-122"/>
                 <a:cs typeface="Calibri" pitchFamily="34" charset="-120"/>
               </a:rPr>
-              <a:t>FastAPI · GenAI · 86% coverage</a:t>
+              <a:t>finoptic-shanto-demo.netlify.app</a:t>
             </a:r>
             <a:endParaRPr lang="en-US" sz="1150" dirty="0"/>
           </a:p>
@@ -3353,12 +3353,12 @@
         </p:nvSpPr>
         <p:spPr>
           <a:xfrm>
-            <a:off x="566928" y="4114800"/>
-            <a:ext cx="11055096" cy="1371600"/>
+            <a:off x="566928" y="3931920"/>
+            <a:ext cx="11055096" cy="1920240"/>
           </a:xfrm>
           <a:prstGeom prst="roundRect">
             <a:avLst>
-              <a:gd name="adj" fmla="val 6000"/>
+              <a:gd name="adj" fmla="val 4286"/>
             </a:avLst>
           </a:prstGeom>
           <a:solidFill>
@@ -3387,8 +3387,8 @@
         </p:nvSpPr>
         <p:spPr>
           <a:xfrm>
-            <a:off x="932688" y="4114800"/>
-            <a:ext cx="10323576" cy="1371600"/>
+            <a:off x="978408" y="3931920"/>
+            <a:ext cx="10232136" cy="1920240"/>
           </a:xfrm>
           <a:prstGeom prst="rect">
             <a:avLst/>
@@ -3401,10 +3401,13 @@
           <a:lstStyle/>
           <a:p>
             <a:pPr indent="0" marL="0">
-              <a:buNone/>
-            </a:pPr>
-            <a:r>
-              <a:rPr lang="en-US" sz="1700" b="1" dirty="0">
+              <a:spcAft>
+                <a:spcPts val="800"/>
+              </a:spcAft>
+              <a:buNone/>
+            </a:pPr>
+            <a:r>
+              <a:rPr lang="en-US" sz="1600" b="1" dirty="0">
                 <a:solidFill>
                   <a:srgbClr val="94AAC6"/>
                 </a:solidFill>
@@ -3412,37 +3415,83 @@
                 <a:ea typeface="Calibri" pitchFamily="34" charset="-122"/>
                 <a:cs typeface="Calibri" pitchFamily="34" charset="-120"/>
               </a:rPr>
-              <a:t>GitHub   </a:t>
+              <a:t>Live demo    </a:t>
             </a:r>
             <a:pPr indent="0" marL="0">
-              <a:buNone/>
-            </a:pPr>
-            <a:r>
-              <a:rPr lang="en-US" sz="1700" b="1" dirty="0">
-                <a:solidFill>
-                  <a:srgbClr val="2DD4BF"/>
+              <a:spcAft>
+                <a:spcPts val="800"/>
+              </a:spcAft>
+              <a:buNone/>
+            </a:pPr>
+            <a:r>
+              <a:rPr lang="en-US" sz="1600" b="1" dirty="0">
+                <a:solidFill>
+                  <a:srgbClr val="34D399"/>
                 </a:solidFill>
                 <a:latin typeface="Calibri" pitchFamily="34" charset="0"/>
                 <a:ea typeface="Calibri" pitchFamily="34" charset="-122"/>
                 <a:cs typeface="Calibri" pitchFamily="34" charset="-120"/>
               </a:rPr>
-              <a:t>github.com/shanto12/finoptic</a:t>
-            </a:r>
+              <a:t>finoptic-shanto-demo.netlify.app</a:t>
+            </a:r>
+            <a:endParaRPr lang="en-US" sz="1600" dirty="0"/>
+          </a:p>
+          <a:p>
             <a:pPr indent="0" marL="0">
-              <a:buNone/>
-            </a:pPr>
-            <a:r>
-              <a:rPr lang="en-US" sz="1700" dirty="0">
-                <a:solidFill>
-                  <a:srgbClr val="E6EEF8"/>
+              <a:spcAft>
+                <a:spcPts val="800"/>
+              </a:spcAft>
+              <a:buNone/>
+            </a:pPr>
+            <a:r>
+              <a:rPr lang="en-US" sz="1600" b="1" dirty="0">
+                <a:solidFill>
+                  <a:srgbClr val="94AAC6"/>
                 </a:solidFill>
                 <a:latin typeface="Calibri" pitchFamily="34" charset="0"/>
                 <a:ea typeface="Calibri" pitchFamily="34" charset="-122"/>
                 <a:cs typeface="Calibri" pitchFamily="34" charset="-120"/>
               </a:rPr>
-              <a:t>          Shanto Mathew</a:t>
-            </a:r>
-            <a:endParaRPr lang="en-US" sz="1700" dirty="0"/>
+              <a:t>GitHub        </a:t>
+            </a:r>
+            <a:pPr indent="0" marL="0">
+              <a:spcAft>
+                <a:spcPts val="800"/>
+              </a:spcAft>
+              <a:buNone/>
+            </a:pPr>
+            <a:r>
+              <a:rPr lang="en-US" sz="1600" b="1" dirty="0">
+                <a:solidFill>
+                  <a:srgbClr val="2DD4BF"/>
+                </a:solidFill>
+                <a:latin typeface="Calibri" pitchFamily="34" charset="0"/>
+                <a:ea typeface="Calibri" pitchFamily="34" charset="-122"/>
+                <a:cs typeface="Calibri" pitchFamily="34" charset="-120"/>
+              </a:rPr>
+              <a:t>github.com/shanto12/finoptic</a:t>
+            </a:r>
+            <a:endParaRPr lang="en-US" sz="1600" dirty="0"/>
+          </a:p>
+          <a:p>
+            <a:pPr indent="0" marL="0">
+              <a:spcAft>
+                <a:spcPts val="800"/>
+              </a:spcAft>
+              <a:buNone/>
+            </a:pPr>
+            <a:r>
+              <a:rPr lang="en-US" sz="1600" dirty="0">
+                <a:solidFill>
+                  <a:srgbClr val="E6EEF8"/>
+                </a:solidFill>
+                <a:latin typeface="Calibri" pitchFamily="34" charset="0"/>
+                <a:ea typeface="Calibri" pitchFamily="34" charset="-122"/>
+                <a:cs typeface="Calibri" pitchFamily="34" charset="-120"/>
+              </a:rPr>
+              <a:t>Shanto Mathew</a:t>
+            </a:r>
+            <a:endParaRPr lang="en-US" sz="1600" dirty="0"/>
           </a:p>
         </p:txBody>
       </p:sp>
@@ -9282,7 +9331,7 @@
                 <a:ea typeface="Calibri" pitchFamily="34" charset="-122"/>
                 <a:cs typeface="Calibri" pitchFamily="34" charset="-120"/>
               </a:rPr>
-              <a:t>50 tests · 86% coverage · ruff · CI 3.11/3.12</a:t>
+              <a:t>51 tests · 86% coverage · ruff · CI 3.11/3.12</a:t>
             </a:r>
             <a:endParaRPr lang="en-US" sz="1300" dirty="0"/>
           </a:p>

</xml_diff>